<commit_message>
Method figure: target encoder shares encoder color; separate z-bar block
Answers the color-semantics issue: the EMA target IS the encoder (weight
copy), so both boxes now share the encoder fill, with the target embedding
z-bar as its own block feeding the loss. Applied to both fig_method.pdf
(figures_paper.py) and fig_method.pptx (fig_method_pptx.py).

Co-Authored-By: Claude Fable 5 <noreply@anthropic.com>
</commit_message>
<xml_diff>
--- a/fig_method.pptx
+++ b/fig_method.pptx
@@ -3789,10 +3789,99 @@
         </p:nvSpPr>
         <p:spPr>
           <a:xfrm>
-            <a:off x="365760" y="3017520"/>
-            <a:ext cx="1737360" cy="914400"/>
+            <a:off x="274320" y="3017520"/>
+            <a:ext cx="1371600" cy="914400"/>
           </a:xfrm>
           <a:prstGeom prst="roundRect">
+            <a:avLst/>
+          </a:prstGeom>
+          <a:solidFill>
+            <a:srgbClr val="DBE9F9"/>
+          </a:solidFill>
+          <a:ln w="12700">
+            <a:solidFill>
+              <a:srgbClr val="6B7280"/>
+            </a:solidFill>
+          </a:ln>
+          <a:effectLst/>
+        </p:spPr>
+        <p:style>
+          <a:lnRef idx="1">
+            <a:schemeClr val="accent1"/>
+          </a:lnRef>
+          <a:fillRef idx="3">
+            <a:schemeClr val="accent1"/>
+          </a:fillRef>
+          <a:effectRef idx="2">
+            <a:schemeClr val="accent1"/>
+          </a:effectRef>
+          <a:fontRef idx="minor">
+            <a:schemeClr val="lt1"/>
+          </a:fontRef>
+        </p:style>
+        <p:txBody>
+          <a:bodyPr rtlCol="0" anchor="ctr" wrap="square"/>
+          <a:lstStyle/>
+          <a:p>
+            <a:pPr algn="ctr"/>
+            <a:r>
+              <a:rPr sz="1300" b="0">
+                <a:solidFill>
+                  <a:srgbClr val="1F2937"/>
+                </a:solidFill>
+              </a:rPr>
+              <a:t>target
+encoder</a:t>
+            </a:r>
+          </a:p>
+        </p:txBody>
+      </p:sp>
+      <p:sp>
+        <p:nvSpPr>
+          <p:cNvPr id="19" name="TextBox 18"/>
+          <p:cNvSpPr txBox="1"/>
+          <p:nvPr/>
+        </p:nvSpPr>
+        <p:spPr>
+          <a:xfrm>
+            <a:off x="274320" y="3950208"/>
+            <a:ext cx="1371600" cy="365760"/>
+          </a:xfrm>
+          <a:prstGeom prst="rect">
+            <a:avLst/>
+          </a:prstGeom>
+          <a:noFill/>
+        </p:spPr>
+        <p:txBody>
+          <a:bodyPr wrap="square">
+            <a:spAutoFit/>
+          </a:bodyPr>
+          <a:lstStyle/>
+          <a:p>
+            <a:pPr algn="ctr"/>
+            <a:r>
+              <a:rPr sz="800" b="0" i="0">
+                <a:solidFill>
+                  <a:srgbClr val="6B7280"/>
+                </a:solidFill>
+              </a:rPr>
+              <a:t>(EMA copy)</a:t>
+            </a:r>
+          </a:p>
+        </p:txBody>
+      </p:sp>
+      <p:sp>
+        <p:nvSpPr>
+          <p:cNvPr id="20" name="Rectangle 19"/>
+          <p:cNvSpPr/>
+          <p:nvPr/>
+        </p:nvSpPr>
+        <p:spPr>
+          <a:xfrm>
+            <a:off x="1783080" y="3127248"/>
+            <a:ext cx="777240" cy="685800"/>
+          </a:xfrm>
+          <a:prstGeom prst="rect">
             <a:avLst/>
           </a:prstGeom>
           <a:solidFill>
@@ -3825,27 +3914,26 @@
           <a:p>
             <a:pPr algn="ctr"/>
             <a:r>
-              <a:rPr sz="1300" b="0">
+              <a:rPr sz="1100" b="0">
                 <a:solidFill>
                   <a:srgbClr val="1F2937"/>
                 </a:solidFill>
               </a:rPr>
-              <a:t>EMA target
-z̄_{t+Δ}</a:t>
+              <a:t>z̄_{t+Δ}</a:t>
             </a:r>
           </a:p>
         </p:txBody>
       </p:sp>
       <p:cxnSp>
         <p:nvCxnSpPr>
-          <p:cNvPr id="19" name="Connector 18"/>
+          <p:cNvPr id="21" name="Connector 20"/>
           <p:cNvCxnSpPr/>
           <p:nvPr/>
         </p:nvCxnSpPr>
         <p:spPr>
-          <a:xfrm flipH="1">
-            <a:off x="2103120" y="3474720"/>
-            <a:ext cx="1005840" cy="0"/>
+          <a:xfrm>
+            <a:off x="1645920" y="3474720"/>
+            <a:ext cx="137160" cy="0"/>
           </a:xfrm>
           <a:prstGeom prst="line">
             <a:avLst/>
@@ -3872,16 +3960,53 @@
           </a:fontRef>
         </p:style>
       </p:cxnSp>
-      <p:sp>
-        <p:nvSpPr>
-          <p:cNvPr id="20" name="TextBox 19"/>
+      <p:cxnSp>
+        <p:nvCxnSpPr>
+          <p:cNvPr id="22" name="Connector 21"/>
+          <p:cNvCxnSpPr/>
+          <p:nvPr/>
+        </p:nvCxnSpPr>
+        <p:spPr>
+          <a:xfrm flipH="1">
+            <a:off x="2560320" y="3474720"/>
+            <a:ext cx="548640" cy="0"/>
+          </a:xfrm>
+          <a:prstGeom prst="line">
+            <a:avLst/>
+          </a:prstGeom>
+          <a:ln w="19050">
+            <a:solidFill>
+              <a:srgbClr val="1F2937"/>
+            </a:solidFill>
+            <a:tailEnd type="triangle"/>
+            <a:headEnd type="triangle"/>
+          </a:ln>
+        </p:spPr>
+        <p:style>
+          <a:lnRef idx="2">
+            <a:schemeClr val="accent1"/>
+          </a:lnRef>
+          <a:fillRef idx="0">
+            <a:schemeClr val="accent1"/>
+          </a:fillRef>
+          <a:effectRef idx="1">
+            <a:schemeClr val="accent1"/>
+          </a:effectRef>
+          <a:fontRef idx="minor">
+            <a:schemeClr val="tx1"/>
+          </a:fontRef>
+        </p:style>
+      </p:cxnSp>
+      <p:sp>
+        <p:nvSpPr>
+          <p:cNvPr id="23" name="TextBox 22"/>
           <p:cNvSpPr txBox="1"/>
           <p:nvPr/>
         </p:nvSpPr>
         <p:spPr>
           <a:xfrm>
-            <a:off x="2057400" y="2999232"/>
-            <a:ext cx="1097280" cy="365760"/>
+            <a:off x="2468880" y="2944368"/>
+            <a:ext cx="822960" cy="365760"/>
           </a:xfrm>
           <a:prstGeom prst="rect">
             <a:avLst/>
@@ -3896,7 +4021,7 @@
           <a:p>
             <a:pPr algn="ctr"/>
             <a:r>
-              <a:rPr sz="900" b="0" i="0">
+              <a:rPr sz="800" b="0" i="0">
                 <a:solidFill>
                   <a:srgbClr val="6B7280"/>
                 </a:solidFill>
@@ -3907,7 +4032,7 @@
           <a:p>
             <a:pPr algn="ctr"/>
             <a:r>
-              <a:rPr sz="900" b="0" i="0">
+              <a:rPr sz="800" b="0" i="0">
                 <a:solidFill>
                   <a:srgbClr val="6B7280"/>
                 </a:solidFill>
@@ -3919,7 +4044,7 @@
       </p:sp>
       <p:sp>
         <p:nvSpPr>
-          <p:cNvPr id="21" name="TextBox 20"/>
+          <p:cNvPr id="24" name="TextBox 23"/>
           <p:cNvSpPr txBox="1"/>
           <p:nvPr/>
         </p:nvSpPr>

</xml_diff>

<commit_message>
Method figure: distinct predictor color, single L2 loss label; sigma/w sentence
- predictor now light violet (distinct from encoder blue) in PDF + PPTX
- method figure shows only the L2 (JEPA) loss; the contrastive variant is
  referenced from F2 in text instead of cluttering the method diagram
- report.tex / report_3p.tex: one-line explanation of sigma (logistic) and
  w (transition width, 4 patches) in the gate definition

Co-Authored-By: Claude Fable 5 <noreply@anthropic.com>
</commit_message>
<xml_diff>
--- a/fig_method.pptx
+++ b/fig_method.pptx
@@ -3624,7 +3624,7 @@
             <a:avLst/>
           </a:prstGeom>
           <a:solidFill>
-            <a:srgbClr val="DBE9F9"/>
+            <a:srgbClr val="E6E1F5"/>
           </a:solidFill>
           <a:ln w="12700">
             <a:solidFill>
@@ -4005,7 +4005,7 @@
         </p:nvSpPr>
         <p:spPr>
           <a:xfrm>
-            <a:off x="2468880" y="2944368"/>
+            <a:off x="2468880" y="3063240"/>
             <a:ext cx="822960" cy="365760"/>
           </a:xfrm>
           <a:prstGeom prst="rect">
@@ -4021,23 +4021,12 @@
           <a:p>
             <a:pPr algn="ctr"/>
             <a:r>
-              <a:rPr sz="800" b="0" i="0">
+              <a:rPr sz="1000" b="0" i="0">
                 <a:solidFill>
                   <a:srgbClr val="6B7280"/>
                 </a:solidFill>
               </a:rPr>
-              <a:t>L₂ /</a:t>
-            </a:r>
-          </a:p>
-          <a:p>
-            <a:pPr algn="ctr"/>
-            <a:r>
-              <a:rPr sz="800" b="0" i="0">
-                <a:solidFill>
-                  <a:srgbClr val="6B7280"/>
-                </a:solidFill>
-              </a:rPr>
-              <a:t>InfoNCE</a:t>
+              <a:t>L₂</a:t>
             </a:r>
           </a:p>
         </p:txBody>

</xml_diff>